<commit_message>
Harden companion presentation generation
</commit_message>
<xml_diff>
--- a/Studies/The-Ontology-of-Coexistence/Coexistence-in-Comparison-MD-vs-Advaita-Philosophy-Science.pptx
+++ b/Studies/The-Ontology-of-Coexistence/Coexistence-in-Comparison-MD-vs-Advaita-Philosophy-Science.pptx
@@ -2,128 +2,33 @@
 <file path=ppt/presentation.xml><?xml version="1.0" encoding="utf-8"?>
 <p:presentation xmlns:p="http://schemas.openxmlformats.org/presentationml/2006/main">
   <p:sldMasterIdLst>
-    <p:sldMasterId xmlns:r="http://schemas.openxmlformats.org/officeDocument/2006/relationships" id="2147483648" r:id="R8aa192d6767647f9"/>
+    <p:sldMasterId xmlns:r="http://schemas.openxmlformats.org/officeDocument/2006/relationships" id="2147483648" r:id="R9d74b22827644129"/>
   </p:sldMasterIdLst>
   <p:notesMasterIdLst>
-    <p:notesMasterId xmlns:r="http://schemas.openxmlformats.org/officeDocument/2006/relationships" r:id="Rb4341bb645f7433e"/>
+    <p:notesMasterId xmlns:r="http://schemas.openxmlformats.org/officeDocument/2006/relationships" r:id="Rc8c9cee1073b4297"/>
   </p:notesMasterIdLst>
   <p:sldIdLst>
-    <p:sldId xmlns:r="http://schemas.openxmlformats.org/officeDocument/2006/relationships" id="256" r:id="Rd248599913654893"/>
-    <p:sldId xmlns:r="http://schemas.openxmlformats.org/officeDocument/2006/relationships" id="257" r:id="R08550a15d9c747f7"/>
-    <p:sldId xmlns:r="http://schemas.openxmlformats.org/officeDocument/2006/relationships" id="258" r:id="Rdb914a694ee14a1a"/>
-    <p:sldId xmlns:r="http://schemas.openxmlformats.org/officeDocument/2006/relationships" id="259" r:id="Re6885e39753641b6"/>
-    <p:sldId xmlns:r="http://schemas.openxmlformats.org/officeDocument/2006/relationships" id="260" r:id="R10f3b66ea3e54e18"/>
-    <p:sldId xmlns:r="http://schemas.openxmlformats.org/officeDocument/2006/relationships" id="261" r:id="R0c4ad2eed2b74b8b"/>
-    <p:sldId xmlns:r="http://schemas.openxmlformats.org/officeDocument/2006/relationships" id="262" r:id="R54de75f1ffed4157"/>
-    <p:sldId xmlns:r="http://schemas.openxmlformats.org/officeDocument/2006/relationships" id="263" r:id="R02a0e6f6e4664a49"/>
-    <p:sldId xmlns:r="http://schemas.openxmlformats.org/officeDocument/2006/relationships" id="264" r:id="R965215b63ca84630"/>
-    <p:sldId xmlns:r="http://schemas.openxmlformats.org/officeDocument/2006/relationships" id="265" r:id="Rfbb586be29e64bc7"/>
-    <p:sldId xmlns:r="http://schemas.openxmlformats.org/officeDocument/2006/relationships" id="266" r:id="Rb44394de6eeb4c88"/>
-    <p:sldId xmlns:r="http://schemas.openxmlformats.org/officeDocument/2006/relationships" id="267" r:id="Rb2e8ef7b4c814f30"/>
-    <p:sldId xmlns:r="http://schemas.openxmlformats.org/officeDocument/2006/relationships" id="268" r:id="R80614fa788604d43"/>
-    <p:sldId xmlns:r="http://schemas.openxmlformats.org/officeDocument/2006/relationships" id="269" r:id="Rf03ca450f683412d"/>
-    <p:sldId xmlns:r="http://schemas.openxmlformats.org/officeDocument/2006/relationships" id="270" r:id="R345ffbb5d36f481c"/>
-    <p:sldId xmlns:r="http://schemas.openxmlformats.org/officeDocument/2006/relationships" id="271" r:id="R867bd1da647d4aa2"/>
-    <p:sldId xmlns:r="http://schemas.openxmlformats.org/officeDocument/2006/relationships" id="272" r:id="R8e9e5d2a8a214f5a"/>
-    <p:sldId xmlns:r="http://schemas.openxmlformats.org/officeDocument/2006/relationships" id="273" r:id="Rcc93124099f24238"/>
+    <p:sldId xmlns:r="http://schemas.openxmlformats.org/officeDocument/2006/relationships" id="256" r:id="R92aa9f857380473e"/>
+    <p:sldId xmlns:r="http://schemas.openxmlformats.org/officeDocument/2006/relationships" id="257" r:id="Rf7c5f76cf5a14211"/>
+    <p:sldId xmlns:r="http://schemas.openxmlformats.org/officeDocument/2006/relationships" id="258" r:id="R52a69491f71f4f37"/>
+    <p:sldId xmlns:r="http://schemas.openxmlformats.org/officeDocument/2006/relationships" id="259" r:id="R342775ee7ca44951"/>
+    <p:sldId xmlns:r="http://schemas.openxmlformats.org/officeDocument/2006/relationships" id="260" r:id="R9aa42f6e6a41438a"/>
+    <p:sldId xmlns:r="http://schemas.openxmlformats.org/officeDocument/2006/relationships" id="261" r:id="Ra905540d0b404d10"/>
+    <p:sldId xmlns:r="http://schemas.openxmlformats.org/officeDocument/2006/relationships" id="262" r:id="Raeaea35503114ad5"/>
+    <p:sldId xmlns:r="http://schemas.openxmlformats.org/officeDocument/2006/relationships" id="263" r:id="Rf3470618da3e4878"/>
+    <p:sldId xmlns:r="http://schemas.openxmlformats.org/officeDocument/2006/relationships" id="264" r:id="Rc29e4432b3654346"/>
+    <p:sldId xmlns:r="http://schemas.openxmlformats.org/officeDocument/2006/relationships" id="265" r:id="R5a10bd9939994467"/>
+    <p:sldId xmlns:r="http://schemas.openxmlformats.org/officeDocument/2006/relationships" id="266" r:id="R0eb661fb203a45df"/>
+    <p:sldId xmlns:r="http://schemas.openxmlformats.org/officeDocument/2006/relationships" id="267" r:id="Rb1c53e70f93f4e00"/>
+    <p:sldId xmlns:r="http://schemas.openxmlformats.org/officeDocument/2006/relationships" id="268" r:id="R84e5390e6c634808"/>
+    <p:sldId xmlns:r="http://schemas.openxmlformats.org/officeDocument/2006/relationships" id="269" r:id="R686ba1bc923448e4"/>
+    <p:sldId xmlns:r="http://schemas.openxmlformats.org/officeDocument/2006/relationships" id="270" r:id="R48c4111260694b37"/>
+    <p:sldId xmlns:r="http://schemas.openxmlformats.org/officeDocument/2006/relationships" id="271" r:id="R5b9c96dbeb1541f3"/>
+    <p:sldId xmlns:r="http://schemas.openxmlformats.org/officeDocument/2006/relationships" id="272" r:id="R98ec1cbfde524283"/>
+    <p:sldId xmlns:r="http://schemas.openxmlformats.org/officeDocument/2006/relationships" id="273" r:id="Re14410c675ed42e0"/>
   </p:sldIdLst>
   <p:sldSz cx="9144000" cy="5143500"/>
   <p:notesSz cx="6858000" cy="9144000"/>
-  <p:defaultTextStyle>
-    <a:defPPr xmlns:a="http://schemas.openxmlformats.org/drawingml/2006/main">
-      <a:defRPr lang="en-US"/>
-    </a:defPPr>
-    <a:lvl1pPr xmlns:a="http://schemas.openxmlformats.org/drawingml/2006/main" marL="0" indent="0" algn="l" defTabSz="914400">
-      <a:defRPr sz="1800" kern="1200">
-        <a:solidFill>
-          <a:schemeClr val="tx1"/>
-        </a:solidFill>
-        <a:latin typeface="+mn-lt"/>
-        <a:ea typeface="+mn-ea"/>
-        <a:cs typeface="+mn-cs"/>
-      </a:defRPr>
-    </a:lvl1pPr>
-    <a:lvl2pPr xmlns:a="http://schemas.openxmlformats.org/drawingml/2006/main" marL="457200" indent="0" algn="l" defTabSz="914400">
-      <a:defRPr sz="1800" kern="1200">
-        <a:solidFill>
-          <a:schemeClr val="tx1"/>
-        </a:solidFill>
-        <a:latin typeface="+mn-lt"/>
-        <a:ea typeface="+mn-ea"/>
-        <a:cs typeface="+mn-cs"/>
-      </a:defRPr>
-    </a:lvl2pPr>
-    <a:lvl3pPr xmlns:a="http://schemas.openxmlformats.org/drawingml/2006/main" marL="914400" indent="0" algn="l" defTabSz="914400">
-      <a:defRPr sz="1800" kern="1200">
-        <a:solidFill>
-          <a:schemeClr val="tx1"/>
-        </a:solidFill>
-        <a:latin typeface="+mn-lt"/>
-        <a:ea typeface="+mn-ea"/>
-        <a:cs typeface="+mn-cs"/>
-      </a:defRPr>
-    </a:lvl3pPr>
-    <a:lvl4pPr xmlns:a="http://schemas.openxmlformats.org/drawingml/2006/main" marL="1371600" indent="0" algn="l" defTabSz="914400">
-      <a:defRPr sz="1800" kern="1200">
-        <a:solidFill>
-          <a:schemeClr val="tx1"/>
-        </a:solidFill>
-        <a:latin typeface="+mn-lt"/>
-        <a:ea typeface="+mn-ea"/>
-        <a:cs typeface="+mn-cs"/>
-      </a:defRPr>
-    </a:lvl4pPr>
-    <a:lvl5pPr xmlns:a="http://schemas.openxmlformats.org/drawingml/2006/main" marL="1828800" indent="0" algn="l" defTabSz="914400">
-      <a:defRPr sz="1800" kern="1200">
-        <a:solidFill>
-          <a:schemeClr val="tx1"/>
-        </a:solidFill>
-        <a:latin typeface="+mn-lt"/>
-        <a:ea typeface="+mn-ea"/>
-        <a:cs typeface="+mn-cs"/>
-      </a:defRPr>
-    </a:lvl5pPr>
-    <a:lvl6pPr xmlns:a="http://schemas.openxmlformats.org/drawingml/2006/main" marL="2286000" indent="0" algn="l" defTabSz="914400">
-      <a:defRPr sz="1800" kern="1200">
-        <a:solidFill>
-          <a:schemeClr val="tx1"/>
-        </a:solidFill>
-        <a:latin typeface="+mn-lt"/>
-        <a:ea typeface="+mn-ea"/>
-        <a:cs typeface="+mn-cs"/>
-      </a:defRPr>
-    </a:lvl6pPr>
-    <a:lvl7pPr xmlns:a="http://schemas.openxmlformats.org/drawingml/2006/main" marL="2743200" indent="0" algn="l" defTabSz="914400">
-      <a:defRPr sz="1800" kern="1200">
-        <a:solidFill>
-          <a:schemeClr val="tx1"/>
-        </a:solidFill>
-        <a:latin typeface="+mn-lt"/>
-        <a:ea typeface="+mn-ea"/>
-        <a:cs typeface="+mn-cs"/>
-      </a:defRPr>
-    </a:lvl7pPr>
-    <a:lvl8pPr xmlns:a="http://schemas.openxmlformats.org/drawingml/2006/main" marL="3200400" indent="0" algn="l" defTabSz="914400">
-      <a:defRPr sz="1800" kern="1200">
-        <a:solidFill>
-          <a:schemeClr val="tx1"/>
-        </a:solidFill>
-        <a:latin typeface="+mn-lt"/>
-        <a:ea typeface="+mn-ea"/>
-        <a:cs typeface="+mn-cs"/>
-      </a:defRPr>
-    </a:lvl8pPr>
-    <a:lvl9pPr xmlns:a="http://schemas.openxmlformats.org/drawingml/2006/main" marL="3657600" indent="0" algn="l" defTabSz="914400">
-      <a:defRPr sz="1800" kern="1200">
-        <a:solidFill>
-          <a:schemeClr val="tx1"/>
-        </a:solidFill>
-        <a:latin typeface="+mn-lt"/>
-        <a:ea typeface="+mn-ea"/>
-        <a:cs typeface="+mn-cs"/>
-      </a:defRPr>
-    </a:lvl9pPr>
-  </p:defaultTextStyle>
 </p:presentation>
 </file>
 
@@ -1999,7 +1904,7 @@
   </p:cSld>
   <p:clrMap bg1="lt1" tx1="dk1" bg2="dk2" tx2="lt2" accent1="accent1" accent2="accent2" accent3="accent3" accent4="accent4" accent5="accent5" accent6="accent6" hlink="hlink" folHlink="folHlink"/>
   <p:sldLayoutIdLst>
-    <p:sldLayoutId xmlns:r="http://schemas.openxmlformats.org/officeDocument/2006/relationships" id="2147483649" r:id="Re48c6f1c50264849"/>
+    <p:sldLayoutId xmlns:r="http://schemas.openxmlformats.org/officeDocument/2006/relationships" id="2147483649" r:id="Rae7ebbb89c6d42b7"/>
   </p:sldLayoutIdLst>
   <p:hf sldNum="0" hdr="0" ftr="0" dt="0"/>
   <p:txStyles>
@@ -3554,7 +3459,7 @@
         </p:nvSpPr>
         <p:spPr>
           <a:xfrm xmlns:a="http://schemas.openxmlformats.org/drawingml/2006/main">
-            <a:off x="640080" y="2880360"/>
+            <a:off x="640080" y="3063240"/>
             <a:ext cx="5120640" cy="365760"/>
           </a:xfrm>
           <a:prstGeom xmlns:a="http://schemas.openxmlformats.org/drawingml/2006/main" prst="rect">

</xml_diff>